<commit_message>
docs: polish daily status presentation
Co-authored-by: 程序员鱼皮 <592789970@qq.com>
</commit_message>
<xml_diff>
--- a/docs/reports/project-status-2026-07-15.pptx
+++ b/docs/reports/project-status-2026-07-15.pptx
@@ -4,6 +4,9 @@
   <p:sldMasterIdLst>
     <p:sldMasterId id="2147483648" r:id="rId1"/>
   </p:sldMasterIdLst>
+  <p:notesMasterIdLst>
+    <p:notesMasterId r:id="rId13"/>
+  </p:notesMasterIdLst>
   <p:sldIdLst>
     <p:sldId id="256" r:id="rId2"/>
     <p:sldId id="257" r:id="rId3"/>
@@ -17,9 +20,6 @@
     <p:sldId id="265" r:id="rId11"/>
     <p:sldId id="266" r:id="rId12"/>
   </p:sldIdLst>
-  <p:notesMasterIdLst>
-    <p:notesMasterId r:id="rId13"/>
-  </p:notesMasterIdLst>
   <p:sldSz cx="12191695" cy="6858000"/>
   <p:notesSz cx="6858000" cy="12191695"/>
   <p:defaultTextStyle>
@@ -2345,7 +2345,7 @@
         </p:nvSpPr>
         <p:spPr>
           <a:xfrm>
-            <a:off x="603504" y="6510528"/>
+            <a:off x="603504" y="6236208"/>
             <a:ext cx="3840480" cy="146304"/>
           </a:xfrm>
           <a:prstGeom prst="rect">
@@ -2384,7 +2384,7 @@
         </p:nvSpPr>
         <p:spPr>
           <a:xfrm>
-            <a:off x="11109960" y="6473952"/>
+            <a:off x="11109960" y="6208776"/>
             <a:ext cx="457200" cy="182880"/>
           </a:xfrm>
           <a:prstGeom prst="rect">
@@ -2455,7 +2455,7 @@
         </p:nvSpPr>
         <p:spPr>
           <a:xfrm>
-            <a:off x="621792" y="347472"/>
+            <a:off x="621792" y="457200"/>
             <a:ext cx="4114800" cy="164592"/>
           </a:xfrm>
           <a:prstGeom prst="rect">
@@ -2494,7 +2494,7 @@
         </p:nvSpPr>
         <p:spPr>
           <a:xfrm>
-            <a:off x="603504" y="621792"/>
+            <a:off x="603504" y="731520"/>
             <a:ext cx="9875520" cy="530352"/>
           </a:xfrm>
           <a:prstGeom prst="rect">
@@ -2533,7 +2533,7 @@
         </p:nvSpPr>
         <p:spPr>
           <a:xfrm>
-            <a:off x="10927080" y="347472"/>
+            <a:off x="10927080" y="457200"/>
             <a:ext cx="640080" cy="640080"/>
           </a:xfrm>
           <a:prstGeom prst="ellipse">
@@ -2558,7 +2558,7 @@
         </p:nvSpPr>
         <p:spPr>
           <a:xfrm>
-            <a:off x="10927080" y="521208"/>
+            <a:off x="10927080" y="630936"/>
             <a:ext cx="640080" cy="219456"/>
           </a:xfrm>
           <a:prstGeom prst="rect">
@@ -2597,7 +2597,7 @@
         </p:nvSpPr>
         <p:spPr>
           <a:xfrm>
-            <a:off x="603504" y="6510528"/>
+            <a:off x="603504" y="6236208"/>
             <a:ext cx="3840480" cy="146304"/>
           </a:xfrm>
           <a:prstGeom prst="rect">
@@ -2616,7 +2616,7 @@
             <a:r>
               <a:rPr lang="en-US" sz="950" b="1" spc="120" kern="0" dirty="0">
                 <a:solidFill>
-                  <a:srgbClr val="6F858C"/>
+                  <a:srgbClr val="5D737A"/>
                 </a:solidFill>
                 <a:latin typeface="Calibri" pitchFamily="34" charset="0"/>
                 <a:ea typeface="Calibri" pitchFamily="34" charset="-122"/>
@@ -2636,7 +2636,7 @@
         </p:nvSpPr>
         <p:spPr>
           <a:xfrm>
-            <a:off x="11109960" y="6473952"/>
+            <a:off x="11109960" y="6208776"/>
             <a:ext cx="457200" cy="182880"/>
           </a:xfrm>
           <a:prstGeom prst="rect">
@@ -2839,7 +2839,7 @@
                 <a:ea typeface="Calibri" pitchFamily="34" charset="-122"/>
                 <a:cs typeface="Calibri" pitchFamily="34" charset="-120"/>
               </a:rPr>
-              <a:t>新增后端单元测试 profile</a:t>
+              <a:t>新增后端离线测试 profile</a:t>
             </a:r>
             <a:endParaRPr lang="en-US" sz="1400" dirty="0"/>
           </a:p>
@@ -2905,7 +2905,7 @@
                 <a:ea typeface="Calibri" pitchFamily="34" charset="-122"/>
                 <a:cs typeface="Calibri" pitchFamily="34" charset="-120"/>
               </a:rPr>
-              <a:t>Mock AI / COS / 截图外部依赖</a:t>
+              <a:t>Mock AI / COS / 截图</a:t>
             </a:r>
             <a:endParaRPr lang="en-US" sz="1400" dirty="0"/>
           </a:p>
@@ -2971,7 +2971,7 @@
                 <a:ea typeface="Calibri" pitchFamily="34" charset="-122"/>
                 <a:cs typeface="Calibri" pitchFamily="34" charset="-120"/>
               </a:rPr>
-              <a:t>接入前端类型检查与基础测试</a:t>
+              <a:t>接入前端类型检查与测试</a:t>
             </a:r>
             <a:endParaRPr lang="en-US" sz="1400" dirty="0"/>
           </a:p>
@@ -3281,7 +3281,7 @@
                 <a:ea typeface="Calibri" pitchFamily="34" charset="-122"/>
                 <a:cs typeface="Calibri" pitchFamily="34" charset="-120"/>
               </a:rPr>
-              <a:t>加入密钥扫描与依赖检查</a:t>
+              <a:t>加入密钥扫描、依赖检查</a:t>
             </a:r>
             <a:endParaRPr lang="en-US" sz="1400" dirty="0"/>
           </a:p>
@@ -3347,7 +3347,7 @@
                 <a:ea typeface="Calibri" pitchFamily="34" charset="-122"/>
                 <a:cs typeface="Calibri" pitchFamily="34" charset="-120"/>
               </a:rPr>
-              <a:t>产出可复现构建与制品</a:t>
+              <a:t>产出可复现构建制品</a:t>
             </a:r>
             <a:endParaRPr lang="en-US" sz="1400" dirty="0"/>
           </a:p>
@@ -3591,7 +3591,7 @@
                 <a:ea typeface="Calibri" pitchFamily="34" charset="-122"/>
                 <a:cs typeface="Calibri" pitchFamily="34" charset="-120"/>
               </a:rPr>
-              <a:t>明确单体或微服务主线</a:t>
+              <a:t>明确单体 / 微服务主线</a:t>
             </a:r>
             <a:endParaRPr lang="en-US" sz="1400" dirty="0"/>
           </a:p>
@@ -3657,7 +3657,7 @@
                 <a:ea typeface="Calibri" pitchFamily="34" charset="-122"/>
                 <a:cs typeface="Calibri" pitchFamily="34" charset="-120"/>
               </a:rPr>
-              <a:t>补统一网关与配置治理</a:t>
+              <a:t>补齐网关与配置治理</a:t>
             </a:r>
             <a:endParaRPr lang="en-US" sz="1400" dirty="0"/>
           </a:p>
@@ -3723,7 +3723,7 @@
                 <a:ea typeface="Calibri" pitchFamily="34" charset="-122"/>
                 <a:cs typeface="Calibri" pitchFamily="34" charset="-120"/>
               </a:rPr>
-              <a:t>对齐工作流、监控和版本矩阵</a:t>
+              <a:t>对齐工作流、监控、版本</a:t>
             </a:r>
             <a:endParaRPr lang="en-US" sz="1400" dirty="0"/>
           </a:p>
@@ -4055,7 +4055,7 @@
         <p:spPr>
           <a:xfrm>
             <a:off x="1536192" y="1975104"/>
-            <a:ext cx="2377440" cy="310896"/>
+            <a:ext cx="2331720" cy="310896"/>
           </a:xfrm>
           <a:prstGeom prst="rect">
             <a:avLst/>
@@ -4093,8 +4093,8 @@
         </p:nvSpPr>
         <p:spPr>
           <a:xfrm>
-            <a:off x="3767328" y="1975104"/>
-            <a:ext cx="4937760" cy="530352"/>
+            <a:off x="4114800" y="1975104"/>
+            <a:ext cx="4590288" cy="530352"/>
           </a:xfrm>
           <a:prstGeom prst="rect">
             <a:avLst/>
@@ -4199,7 +4199,7 @@
         <p:spPr>
           <a:xfrm>
             <a:off x="1536192" y="3026664"/>
-            <a:ext cx="2377440" cy="310896"/>
+            <a:ext cx="2331720" cy="310896"/>
           </a:xfrm>
           <a:prstGeom prst="rect">
             <a:avLst/>
@@ -4237,8 +4237,8 @@
         </p:nvSpPr>
         <p:spPr>
           <a:xfrm>
-            <a:off x="3767328" y="3026664"/>
-            <a:ext cx="4937760" cy="530352"/>
+            <a:off x="4114800" y="3026664"/>
+            <a:ext cx="4590288" cy="530352"/>
           </a:xfrm>
           <a:prstGeom prst="rect">
             <a:avLst/>
@@ -4343,7 +4343,7 @@
         <p:spPr>
           <a:xfrm>
             <a:off x="1536192" y="4078224"/>
-            <a:ext cx="2377440" cy="310896"/>
+            <a:ext cx="2331720" cy="310896"/>
           </a:xfrm>
           <a:prstGeom prst="rect">
             <a:avLst/>
@@ -4381,8 +4381,8 @@
         </p:nvSpPr>
         <p:spPr>
           <a:xfrm>
-            <a:off x="3767328" y="4078224"/>
-            <a:ext cx="4937760" cy="530352"/>
+            <a:off x="4114800" y="4078224"/>
+            <a:ext cx="4590288" cy="530352"/>
           </a:xfrm>
           <a:prstGeom prst="rect">
             <a:avLst/>
@@ -4408,7 +4408,7 @@
                 <a:ea typeface="Calibri" pitchFamily="34" charset="-122"/>
                 <a:cs typeface="Calibri" pitchFamily="34" charset="-120"/>
               </a:rPr>
-              <a:t>建议把离线可测、自动构建、配置治理作为恢复开发节奏的第一批任务。</a:t>
+              <a:t>建议先建设离线可测、自动构建与配置治理，再恢复功能开发。</a:t>
             </a:r>
             <a:endParaRPr lang="en-US" sz="1420" dirty="0"/>
           </a:p>
@@ -4568,7 +4568,46 @@
               <a:buNone/>
             </a:pPr>
             <a:r>
-              <a:rPr lang="en-US" sz="1150" dirty="0">
+              <a:rPr lang="en-US" sz="1250" dirty="0">
+                <a:solidFill>
+                  <a:srgbClr val="D5F1EE"/>
+                </a:solidFill>
+                <a:latin typeface="Calibri" pitchFamily="34" charset="0"/>
+                <a:ea typeface="Calibri" pitchFamily="34" charset="-122"/>
+                <a:cs typeface="Calibri" pitchFamily="34" charset="-120"/>
+              </a:rPr>
+              <a:t>报告路径：docs/reports/project-status-2026-07-15.pptx</a:t>
+            </a:r>
+            <a:endParaRPr lang="en-US" sz="1250" dirty="0"/>
+          </a:p>
+        </p:txBody>
+      </p:sp>
+      <p:sp>
+        <p:nvSpPr>
+          <p:cNvPr id="21" name="Text 19"/>
+          <p:cNvSpPr/>
+          <p:nvPr/>
+        </p:nvSpPr>
+        <p:spPr>
+          <a:xfrm>
+            <a:off x="603504" y="6236208"/>
+            <a:ext cx="3840480" cy="146304"/>
+          </a:xfrm>
+          <a:prstGeom prst="rect">
+            <a:avLst/>
+          </a:prstGeom>
+          <a:noFill/>
+          <a:ln/>
+        </p:spPr>
+        <p:txBody>
+          <a:bodyPr wrap="square" lIns="0" tIns="0" rIns="0" bIns="0" rtlCol="0" anchor="ctr"/>
+          <a:lstStyle/>
+          <a:p>
+            <a:pPr indent="0" marL="0">
+              <a:buNone/>
+            </a:pPr>
+            <a:r>
+              <a:rPr lang="en-US" sz="950" b="1" spc="120" kern="0" dirty="0">
                 <a:solidFill>
                   <a:srgbClr val="A6D9D3"/>
                 </a:solidFill>
@@ -4576,45 +4615,6 @@
                 <a:ea typeface="Calibri" pitchFamily="34" charset="-122"/>
                 <a:cs typeface="Calibri" pitchFamily="34" charset="-120"/>
               </a:rPr>
-              <a:t>报告路径：docs/reports/project-status-2026-07-15.pptx</a:t>
-            </a:r>
-            <a:endParaRPr lang="en-US" sz="1150" dirty="0"/>
-          </a:p>
-        </p:txBody>
-      </p:sp>
-      <p:sp>
-        <p:nvSpPr>
-          <p:cNvPr id="21" name="Text 19"/>
-          <p:cNvSpPr/>
-          <p:nvPr/>
-        </p:nvSpPr>
-        <p:spPr>
-          <a:xfrm>
-            <a:off x="603504" y="6510528"/>
-            <a:ext cx="3840480" cy="146304"/>
-          </a:xfrm>
-          <a:prstGeom prst="rect">
-            <a:avLst/>
-          </a:prstGeom>
-          <a:noFill/>
-          <a:ln/>
-        </p:spPr>
-        <p:txBody>
-          <a:bodyPr wrap="square" lIns="0" tIns="0" rIns="0" bIns="0" rtlCol="0" anchor="ctr"/>
-          <a:lstStyle/>
-          <a:p>
-            <a:pPr indent="0" marL="0">
-              <a:buNone/>
-            </a:pPr>
-            <a:r>
-              <a:rPr lang="en-US" sz="950" b="1" spc="120" kern="0" dirty="0">
-                <a:solidFill>
-                  <a:srgbClr val="A6D9D3"/>
-                </a:solidFill>
-                <a:latin typeface="Calibri" pitchFamily="34" charset="0"/>
-                <a:ea typeface="Calibri" pitchFamily="34" charset="-122"/>
-                <a:cs typeface="Calibri" pitchFamily="34" charset="-120"/>
-              </a:rPr>
               <a:t>YU AI CODE MOTHER  ·  DAILY STATUS</a:t>
             </a:r>
             <a:endParaRPr lang="en-US" sz="950" dirty="0"/>
@@ -4629,7 +4629,7 @@
         </p:nvSpPr>
         <p:spPr>
           <a:xfrm>
-            <a:off x="11109960" y="6473952"/>
+            <a:off x="11109960" y="6208776"/>
             <a:ext cx="457200" cy="182880"/>
           </a:xfrm>
           <a:prstGeom prst="rect">
@@ -4700,7 +4700,7 @@
         </p:nvSpPr>
         <p:spPr>
           <a:xfrm>
-            <a:off x="621792" y="347472"/>
+            <a:off x="621792" y="457200"/>
             <a:ext cx="4114800" cy="164592"/>
           </a:xfrm>
           <a:prstGeom prst="rect">
@@ -4739,7 +4739,7 @@
         </p:nvSpPr>
         <p:spPr>
           <a:xfrm>
-            <a:off x="603504" y="621792"/>
+            <a:off x="603504" y="731520"/>
             <a:ext cx="9875520" cy="530352"/>
           </a:xfrm>
           <a:prstGeom prst="rect">
@@ -4778,7 +4778,7 @@
         </p:nvSpPr>
         <p:spPr>
           <a:xfrm>
-            <a:off x="10927080" y="347472"/>
+            <a:off x="10927080" y="457200"/>
             <a:ext cx="640080" cy="640080"/>
           </a:xfrm>
           <a:prstGeom prst="ellipse">
@@ -4803,7 +4803,7 @@
         </p:nvSpPr>
         <p:spPr>
           <a:xfrm>
-            <a:off x="10927080" y="521208"/>
+            <a:off x="10927080" y="630936"/>
             <a:ext cx="640080" cy="219456"/>
           </a:xfrm>
           <a:prstGeom prst="rect">
@@ -4842,7 +4842,7 @@
         </p:nvSpPr>
         <p:spPr>
           <a:xfrm>
-            <a:off x="603504" y="6510528"/>
+            <a:off x="603504" y="6236208"/>
             <a:ext cx="3840480" cy="146304"/>
           </a:xfrm>
           <a:prstGeom prst="rect">
@@ -4861,7 +4861,7 @@
             <a:r>
               <a:rPr lang="en-US" sz="950" b="1" spc="120" kern="0" dirty="0">
                 <a:solidFill>
-                  <a:srgbClr val="6F858C"/>
+                  <a:srgbClr val="5D737A"/>
                 </a:solidFill>
                 <a:latin typeface="Calibri" pitchFamily="34" charset="0"/>
                 <a:ea typeface="Calibri" pitchFamily="34" charset="-122"/>
@@ -4881,7 +4881,7 @@
         </p:nvSpPr>
         <p:spPr>
           <a:xfrm>
-            <a:off x="11109960" y="6473952"/>
+            <a:off x="11109960" y="6208776"/>
             <a:ext cx="457200" cy="182880"/>
           </a:xfrm>
           <a:prstGeom prst="rect">
@@ -5071,7 +5071,7 @@
             <a:r>
               <a:rPr lang="en-US" sz="1150" dirty="0">
                 <a:solidFill>
-                  <a:srgbClr val="6F858C"/>
+                  <a:srgbClr val="5D737A"/>
                 </a:solidFill>
                 <a:latin typeface="Calibri" pitchFamily="34" charset="0"/>
                 <a:ea typeface="Calibri" pitchFamily="34" charset="-122"/>
@@ -5242,7 +5242,7 @@
             <a:r>
               <a:rPr lang="en-US" sz="1150" dirty="0">
                 <a:solidFill>
-                  <a:srgbClr val="6F858C"/>
+                  <a:srgbClr val="5D737A"/>
                 </a:solidFill>
                 <a:latin typeface="Calibri" pitchFamily="34" charset="0"/>
                 <a:ea typeface="Calibri" pitchFamily="34" charset="-122"/>
@@ -5413,13 +5413,13 @@
             <a:r>
               <a:rPr lang="en-US" sz="1150" dirty="0">
                 <a:solidFill>
-                  <a:srgbClr val="6F858C"/>
-                </a:solidFill>
-                <a:latin typeface="Calibri" pitchFamily="34" charset="0"/>
-                <a:ea typeface="Calibri" pitchFamily="34" charset="-122"/>
-                <a:cs typeface="Calibri" pitchFamily="34" charset="-120"/>
-              </a:rPr>
-              <a:t>common / model / client 等</a:t>
+                  <a:srgbClr val="5D737A"/>
+                </a:solidFill>
+                <a:latin typeface="Calibri" pitchFamily="34" charset="0"/>
+                <a:ea typeface="Calibri" pitchFamily="34" charset="-122"/>
+                <a:cs typeface="Calibri" pitchFamily="34" charset="-120"/>
+              </a:rPr>
+              <a:t>模块分层协作</a:t>
             </a:r>
             <a:endParaRPr lang="en-US" sz="1150" dirty="0"/>
           </a:p>
@@ -5584,7 +5584,7 @@
             <a:r>
               <a:rPr lang="en-US" sz="1150" dirty="0">
                 <a:solidFill>
-                  <a:srgbClr val="6F858C"/>
+                  <a:srgbClr val="5D737A"/>
                 </a:solidFill>
                 <a:latin typeface="Calibri" pitchFamily="34" charset="0"/>
                 <a:ea typeface="Calibri" pitchFamily="34" charset="-122"/>
@@ -5809,7 +5809,7 @@
         </p:nvSpPr>
         <p:spPr>
           <a:xfrm>
-            <a:off x="621792" y="347472"/>
+            <a:off x="621792" y="457200"/>
             <a:ext cx="4114800" cy="164592"/>
           </a:xfrm>
           <a:prstGeom prst="rect">
@@ -5848,7 +5848,7 @@
         </p:nvSpPr>
         <p:spPr>
           <a:xfrm>
-            <a:off x="603504" y="621792"/>
+            <a:off x="603504" y="731520"/>
             <a:ext cx="9875520" cy="530352"/>
           </a:xfrm>
           <a:prstGeom prst="rect">
@@ -5887,7 +5887,7 @@
         </p:nvSpPr>
         <p:spPr>
           <a:xfrm>
-            <a:off x="10927080" y="347472"/>
+            <a:off x="10927080" y="457200"/>
             <a:ext cx="640080" cy="640080"/>
           </a:xfrm>
           <a:prstGeom prst="ellipse">
@@ -5912,7 +5912,7 @@
         </p:nvSpPr>
         <p:spPr>
           <a:xfrm>
-            <a:off x="10927080" y="521208"/>
+            <a:off x="10927080" y="630936"/>
             <a:ext cx="640080" cy="219456"/>
           </a:xfrm>
           <a:prstGeom prst="rect">
@@ -5951,7 +5951,7 @@
         </p:nvSpPr>
         <p:spPr>
           <a:xfrm>
-            <a:off x="603504" y="6510528"/>
+            <a:off x="603504" y="6236208"/>
             <a:ext cx="3840480" cy="146304"/>
           </a:xfrm>
           <a:prstGeom prst="rect">
@@ -5970,7 +5970,7 @@
             <a:r>
               <a:rPr lang="en-US" sz="950" b="1" spc="120" kern="0" dirty="0">
                 <a:solidFill>
-                  <a:srgbClr val="6F858C"/>
+                  <a:srgbClr val="5D737A"/>
                 </a:solidFill>
                 <a:latin typeface="Calibri" pitchFamily="34" charset="0"/>
                 <a:ea typeface="Calibri" pitchFamily="34" charset="-122"/>
@@ -5990,7 +5990,7 @@
         </p:nvSpPr>
         <p:spPr>
           <a:xfrm>
-            <a:off x="11109960" y="6473952"/>
+            <a:off x="11109960" y="6208776"/>
             <a:ext cx="457200" cy="182880"/>
           </a:xfrm>
           <a:prstGeom prst="rect">
@@ -6230,8 +6230,8 @@
         </p:nvSpPr>
         <p:spPr>
           <a:xfrm>
-            <a:off x="1444752" y="2560320"/>
-            <a:ext cx="1810512" cy="310896"/>
+            <a:off x="1389888" y="2560320"/>
+            <a:ext cx="1938528" cy="384048"/>
           </a:xfrm>
           <a:prstGeom prst="rect">
             <a:avLst/>
@@ -6249,7 +6249,7 @@
               <a:buNone/>
             </a:pPr>
             <a:r>
-              <a:rPr lang="en-US" sz="1450" b="1" dirty="0">
+              <a:rPr lang="en-US" sz="1320" b="1" dirty="0">
                 <a:solidFill>
                   <a:srgbClr val="143642"/>
                 </a:solidFill>
@@ -6259,7 +6259,7 @@
               </a:rPr>
               <a:t>Vue 3 + TypeScript</a:t>
             </a:r>
-            <a:endParaRPr lang="en-US" sz="1450" dirty="0"/>
+            <a:endParaRPr lang="en-US" sz="1320" dirty="0"/>
           </a:p>
         </p:txBody>
       </p:sp>
@@ -6335,8 +6335,8 @@
         </p:nvSpPr>
         <p:spPr>
           <a:xfrm>
-            <a:off x="1444752" y="3364992"/>
-            <a:ext cx="1810512" cy="310896"/>
+            <a:off x="1389888" y="3364992"/>
+            <a:ext cx="1938528" cy="384048"/>
           </a:xfrm>
           <a:prstGeom prst="rect">
             <a:avLst/>
@@ -6354,7 +6354,7 @@
               <a:buNone/>
             </a:pPr>
             <a:r>
-              <a:rPr lang="en-US" sz="1450" dirty="0">
+              <a:rPr lang="en-US" sz="1320" dirty="0">
                 <a:solidFill>
                   <a:srgbClr val="143642"/>
                 </a:solidFill>
@@ -6364,7 +6364,7 @@
               </a:rPr>
               <a:t>8 个核心页面</a:t>
             </a:r>
-            <a:endParaRPr lang="en-US" sz="1450" dirty="0"/>
+            <a:endParaRPr lang="en-US" sz="1320" dirty="0"/>
           </a:p>
         </p:txBody>
       </p:sp>
@@ -6440,8 +6440,8 @@
         </p:nvSpPr>
         <p:spPr>
           <a:xfrm>
-            <a:off x="1444752" y="4169664"/>
-            <a:ext cx="1810512" cy="310896"/>
+            <a:off x="1389888" y="4169664"/>
+            <a:ext cx="1938528" cy="384048"/>
           </a:xfrm>
           <a:prstGeom prst="rect">
             <a:avLst/>
@@ -6459,7 +6459,7 @@
               <a:buNone/>
             </a:pPr>
             <a:r>
-              <a:rPr lang="en-US" sz="1450" dirty="0">
+              <a:rPr lang="en-US" sz="1320" dirty="0">
                 <a:solidFill>
                   <a:srgbClr val="143642"/>
                 </a:solidFill>
@@ -6469,7 +6469,7 @@
               </a:rPr>
               <a:t>SSE + iframe 实时预览</a:t>
             </a:r>
-            <a:endParaRPr lang="en-US" sz="1450" dirty="0"/>
+            <a:endParaRPr lang="en-US" sz="1320" dirty="0"/>
           </a:p>
         </p:txBody>
       </p:sp>
@@ -6498,9 +6498,9 @@
               <a:buNone/>
             </a:pPr>
             <a:r>
-              <a:rPr lang="en-US" sz="1100" i="1" dirty="0">
-                <a:solidFill>
-                  <a:srgbClr val="6F858C"/>
+              <a:rPr lang="en-US" sz="1200" i="1" dirty="0">
+                <a:solidFill>
+                  <a:srgbClr val="49666F"/>
                 </a:solidFill>
                 <a:latin typeface="Calibri" pitchFamily="34" charset="0"/>
                 <a:ea typeface="Calibri" pitchFamily="34" charset="-122"/>
@@ -6508,7 +6508,7 @@
               </a:rPr>
               <a:t>前端默认对接单体 8123/api</a:t>
             </a:r>
-            <a:endParaRPr lang="en-US" sz="1100" dirty="0"/>
+            <a:endParaRPr lang="en-US" sz="1200" dirty="0"/>
           </a:p>
         </p:txBody>
       </p:sp>
@@ -6721,8 +6721,8 @@
         </p:nvSpPr>
         <p:spPr>
           <a:xfrm>
-            <a:off x="4873752" y="2560320"/>
-            <a:ext cx="1810512" cy="310896"/>
+            <a:off x="4818888" y="2560320"/>
+            <a:ext cx="1938528" cy="384048"/>
           </a:xfrm>
           <a:prstGeom prst="rect">
             <a:avLst/>
@@ -6740,7 +6740,7 @@
               <a:buNone/>
             </a:pPr>
             <a:r>
-              <a:rPr lang="en-US" sz="1450" b="1" dirty="0">
+              <a:rPr lang="en-US" sz="1320" b="1" dirty="0">
                 <a:solidFill>
                   <a:srgbClr val="143642"/>
                 </a:solidFill>
@@ -6750,7 +6750,7 @@
               </a:rPr>
               <a:t>Spring Boot 3 / Java 21</a:t>
             </a:r>
-            <a:endParaRPr lang="en-US" sz="1450" dirty="0"/>
+            <a:endParaRPr lang="en-US" sz="1320" dirty="0"/>
           </a:p>
         </p:txBody>
       </p:sp>
@@ -6826,8 +6826,8 @@
         </p:nvSpPr>
         <p:spPr>
           <a:xfrm>
-            <a:off x="4873752" y="3364992"/>
-            <a:ext cx="1810512" cy="310896"/>
+            <a:off x="4818888" y="3364992"/>
+            <a:ext cx="1938528" cy="384048"/>
           </a:xfrm>
           <a:prstGeom prst="rect">
             <a:avLst/>
@@ -6845,7 +6845,7 @@
               <a:buNone/>
             </a:pPr>
             <a:r>
-              <a:rPr lang="en-US" sz="1450" dirty="0">
+              <a:rPr lang="en-US" sz="1320" dirty="0">
                 <a:solidFill>
                   <a:srgbClr val="143642"/>
                 </a:solidFill>
@@ -6855,7 +6855,7 @@
               </a:rPr>
               <a:t>LangChain4j 工具调用</a:t>
             </a:r>
-            <a:endParaRPr lang="en-US" sz="1450" dirty="0"/>
+            <a:endParaRPr lang="en-US" sz="1320" dirty="0"/>
           </a:p>
         </p:txBody>
       </p:sp>
@@ -6931,8 +6931,8 @@
         </p:nvSpPr>
         <p:spPr>
           <a:xfrm>
-            <a:off x="4873752" y="4169664"/>
-            <a:ext cx="1810512" cy="310896"/>
+            <a:off x="4818888" y="4169664"/>
+            <a:ext cx="1938528" cy="384048"/>
           </a:xfrm>
           <a:prstGeom prst="rect">
             <a:avLst/>
@@ -6950,7 +6950,7 @@
               <a:buNone/>
             </a:pPr>
             <a:r>
-              <a:rPr lang="en-US" sz="1450" dirty="0">
+              <a:rPr lang="en-US" sz="1320" dirty="0">
                 <a:solidFill>
                   <a:srgbClr val="143642"/>
                 </a:solidFill>
@@ -6960,7 +6960,7 @@
               </a:rPr>
               <a:t>LangGraph4j 工作流</a:t>
             </a:r>
-            <a:endParaRPr lang="en-US" sz="1450" dirty="0"/>
+            <a:endParaRPr lang="en-US" sz="1320" dirty="0"/>
           </a:p>
         </p:txBody>
       </p:sp>
@@ -6989,9 +6989,9 @@
               <a:buNone/>
             </a:pPr>
             <a:r>
-              <a:rPr lang="en-US" sz="1100" i="1" dirty="0">
-                <a:solidFill>
-                  <a:srgbClr val="6F858C"/>
+              <a:rPr lang="en-US" sz="1200" i="1" dirty="0">
+                <a:solidFill>
+                  <a:srgbClr val="49666F"/>
                 </a:solidFill>
                 <a:latin typeface="Calibri" pitchFamily="34" charset="0"/>
                 <a:ea typeface="Calibri" pitchFamily="34" charset="-122"/>
@@ -6999,7 +6999,7 @@
               </a:rPr>
               <a:t>单体能力目前更完整</a:t>
             </a:r>
-            <a:endParaRPr lang="en-US" sz="1100" dirty="0"/>
+            <a:endParaRPr lang="en-US" sz="1200" dirty="0"/>
           </a:p>
         </p:txBody>
       </p:sp>
@@ -7212,8 +7212,8 @@
         </p:nvSpPr>
         <p:spPr>
           <a:xfrm>
-            <a:off x="8302752" y="2560320"/>
-            <a:ext cx="1810512" cy="310896"/>
+            <a:off x="8247888" y="2560320"/>
+            <a:ext cx="1938528" cy="384048"/>
           </a:xfrm>
           <a:prstGeom prst="rect">
             <a:avLst/>
@@ -7231,7 +7231,7 @@
               <a:buNone/>
             </a:pPr>
             <a:r>
-              <a:rPr lang="en-US" sz="1450" b="1" dirty="0">
+              <a:rPr lang="en-US" sz="1320" b="1" dirty="0">
                 <a:solidFill>
                   <a:srgbClr val="143642"/>
                 </a:solidFill>
@@ -7241,7 +7241,7 @@
               </a:rPr>
               <a:t>MySQL + Redis</a:t>
             </a:r>
-            <a:endParaRPr lang="en-US" sz="1450" dirty="0"/>
+            <a:endParaRPr lang="en-US" sz="1320" dirty="0"/>
           </a:p>
         </p:txBody>
       </p:sp>
@@ -7317,8 +7317,8 @@
         </p:nvSpPr>
         <p:spPr>
           <a:xfrm>
-            <a:off x="8302752" y="3364992"/>
-            <a:ext cx="1810512" cy="310896"/>
+            <a:off x="8247888" y="3364992"/>
+            <a:ext cx="1938528" cy="384048"/>
           </a:xfrm>
           <a:prstGeom prst="rect">
             <a:avLst/>
@@ -7336,7 +7336,7 @@
               <a:buNone/>
             </a:pPr>
             <a:r>
-              <a:rPr lang="en-US" sz="1450" dirty="0">
+              <a:rPr lang="en-US" sz="1320" dirty="0">
                 <a:solidFill>
                   <a:srgbClr val="143642"/>
                 </a:solidFill>
@@ -7346,7 +7346,7 @@
               </a:rPr>
               <a:t>COS + Selenium 截图</a:t>
             </a:r>
-            <a:endParaRPr lang="en-US" sz="1450" dirty="0"/>
+            <a:endParaRPr lang="en-US" sz="1320" dirty="0"/>
           </a:p>
         </p:txBody>
       </p:sp>
@@ -7422,8 +7422,8 @@
         </p:nvSpPr>
         <p:spPr>
           <a:xfrm>
-            <a:off x="8302752" y="4169664"/>
-            <a:ext cx="1810512" cy="310896"/>
+            <a:off x="8247888" y="4169664"/>
+            <a:ext cx="1938528" cy="384048"/>
           </a:xfrm>
           <a:prstGeom prst="rect">
             <a:avLst/>
@@ -7441,7 +7441,7 @@
               <a:buNone/>
             </a:pPr>
             <a:r>
-              <a:rPr lang="en-US" sz="1450" dirty="0">
+              <a:rPr lang="en-US" sz="1320" dirty="0">
                 <a:solidFill>
                   <a:srgbClr val="143642"/>
                 </a:solidFill>
@@ -7451,7 +7451,7 @@
               </a:rPr>
               <a:t>Nacos + Dubbo / Prometheus</a:t>
             </a:r>
-            <a:endParaRPr lang="en-US" sz="1450" dirty="0"/>
+            <a:endParaRPr lang="en-US" sz="1320" dirty="0"/>
           </a:p>
         </p:txBody>
       </p:sp>
@@ -7480,9 +7480,9 @@
               <a:buNone/>
             </a:pPr>
             <a:r>
-              <a:rPr lang="en-US" sz="1100" i="1" dirty="0">
-                <a:solidFill>
-                  <a:srgbClr val="6F858C"/>
+              <a:rPr lang="en-US" sz="1200" i="1" dirty="0">
+                <a:solidFill>
+                  <a:srgbClr val="49666F"/>
                 </a:solidFill>
                 <a:latin typeface="Calibri" pitchFamily="34" charset="0"/>
                 <a:ea typeface="Calibri" pitchFamily="34" charset="-122"/>
@@ -7490,7 +7490,7 @@
               </a:rPr>
               <a:t>多项外部服务需配置密钥</a:t>
             </a:r>
-            <a:endParaRPr lang="en-US" sz="1100" dirty="0"/>
+            <a:endParaRPr lang="en-US" sz="1200" dirty="0"/>
           </a:p>
         </p:txBody>
       </p:sp>
@@ -7584,7 +7584,7 @@
         </p:nvSpPr>
         <p:spPr>
           <a:xfrm>
-            <a:off x="621792" y="347472"/>
+            <a:off x="621792" y="457200"/>
             <a:ext cx="4114800" cy="164592"/>
           </a:xfrm>
           <a:prstGeom prst="rect">
@@ -7623,7 +7623,7 @@
         </p:nvSpPr>
         <p:spPr>
           <a:xfrm>
-            <a:off x="603504" y="621792"/>
+            <a:off x="603504" y="731520"/>
             <a:ext cx="9875520" cy="530352"/>
           </a:xfrm>
           <a:prstGeom prst="rect">
@@ -7662,7 +7662,7 @@
         </p:nvSpPr>
         <p:spPr>
           <a:xfrm>
-            <a:off x="10927080" y="347472"/>
+            <a:off x="10927080" y="457200"/>
             <a:ext cx="640080" cy="640080"/>
           </a:xfrm>
           <a:prstGeom prst="ellipse">
@@ -7687,7 +7687,7 @@
         </p:nvSpPr>
         <p:spPr>
           <a:xfrm>
-            <a:off x="10927080" y="521208"/>
+            <a:off x="10927080" y="630936"/>
             <a:ext cx="640080" cy="219456"/>
           </a:xfrm>
           <a:prstGeom prst="rect">
@@ -7726,7 +7726,7 @@
         </p:nvSpPr>
         <p:spPr>
           <a:xfrm>
-            <a:off x="603504" y="6510528"/>
+            <a:off x="603504" y="6236208"/>
             <a:ext cx="3840480" cy="146304"/>
           </a:xfrm>
           <a:prstGeom prst="rect">
@@ -7745,7 +7745,7 @@
             <a:r>
               <a:rPr lang="en-US" sz="950" b="1" spc="120" kern="0" dirty="0">
                 <a:solidFill>
-                  <a:srgbClr val="6F858C"/>
+                  <a:srgbClr val="5D737A"/>
                 </a:solidFill>
                 <a:latin typeface="Calibri" pitchFamily="34" charset="0"/>
                 <a:ea typeface="Calibri" pitchFamily="34" charset="-122"/>
@@ -7765,7 +7765,7 @@
         </p:nvSpPr>
         <p:spPr>
           <a:xfrm>
-            <a:off x="11109960" y="6473952"/>
+            <a:off x="11109960" y="6208776"/>
             <a:ext cx="457200" cy="182880"/>
           </a:xfrm>
           <a:prstGeom prst="rect">
@@ -7968,7 +7968,7 @@
                 <a:ea typeface="Calibri" pitchFamily="34" charset="-122"/>
                 <a:cs typeface="Calibri" pitchFamily="34" charset="-120"/>
               </a:rPr>
-              <a:t>输入需求后自动路由 HTML、多文件或 Vue 工程策略；以 SSE 流式展示 AI 执行，并通过工具调用落盘代码。</a:t>
+              <a:t>输入需求后自动路由 HTML、多文件或 Vue 工程；SSE 流式展示执行过程，工具调用将代码写入文件。</a:t>
             </a:r>
             <a:endParaRPr lang="en-US" sz="1420" dirty="0"/>
           </a:p>
@@ -8146,7 +8146,7 @@
                 <a:ea typeface="Calibri" pitchFamily="34" charset="-122"/>
                 <a:cs typeface="Calibri" pitchFamily="34" charset="-120"/>
               </a:rPr>
-              <a:t>右侧 iframe 即时预览生成物；支持点选页面元素、携带上下文继续对话修改，缩短迭代路径。</a:t>
+              <a:t>iframe 即时预览生成物；点选页面元素后携带上下文继续对话，快速完成修改。</a:t>
             </a:r>
             <a:endParaRPr lang="en-US" sz="1420" dirty="0"/>
           </a:p>
@@ -8324,7 +8324,7 @@
                 <a:ea typeface="Calibri" pitchFamily="34" charset="-122"/>
                 <a:cs typeface="Calibri" pitchFamily="34" charset="-120"/>
               </a:rPr>
-              <a:t>一键部署获得分享地址；Selenium 自动截图并上传 COS；同时提供完整项目 ZIP 下载。</a:t>
+              <a:t>一键部署并生成分享地址；Selenium 自动截图上传 COS；支持下载完整项目 ZIP。</a:t>
             </a:r>
             <a:endParaRPr lang="en-US" sz="1420" dirty="0"/>
           </a:p>
@@ -8502,7 +8502,7 @@
                 <a:ea typeface="Calibri" pitchFamily="34" charset="-122"/>
                 <a:cs typeface="Calibri" pitchFamily="34" charset="-120"/>
               </a:rPr>
-              <a:t>Session + Redis 共享登录态，AOP 权限校验；含用户、应用和对话管理，以及精选案例与 AI 指标监控。</a:t>
+              <a:t>Session + Redis 管理登录态，AOP 校验权限；提供用户、应用、对话管理与精选、AI 指标。</a:t>
             </a:r>
             <a:endParaRPr lang="en-US" sz="1420" dirty="0"/>
           </a:p>
@@ -8548,7 +8548,7 @@
         </p:nvSpPr>
         <p:spPr>
           <a:xfrm>
-            <a:off x="621792" y="347472"/>
+            <a:off x="621792" y="457200"/>
             <a:ext cx="4114800" cy="164592"/>
           </a:xfrm>
           <a:prstGeom prst="rect">
@@ -8587,7 +8587,7 @@
         </p:nvSpPr>
         <p:spPr>
           <a:xfrm>
-            <a:off x="603504" y="621792"/>
+            <a:off x="603504" y="731520"/>
             <a:ext cx="9875520" cy="530352"/>
           </a:xfrm>
           <a:prstGeom prst="rect">
@@ -8626,7 +8626,7 @@
         </p:nvSpPr>
         <p:spPr>
           <a:xfrm>
-            <a:off x="10927080" y="347472"/>
+            <a:off x="10927080" y="457200"/>
             <a:ext cx="640080" cy="640080"/>
           </a:xfrm>
           <a:prstGeom prst="ellipse">
@@ -8651,7 +8651,7 @@
         </p:nvSpPr>
         <p:spPr>
           <a:xfrm>
-            <a:off x="10927080" y="521208"/>
+            <a:off x="10927080" y="630936"/>
             <a:ext cx="640080" cy="219456"/>
           </a:xfrm>
           <a:prstGeom prst="rect">
@@ -8690,7 +8690,7 @@
         </p:nvSpPr>
         <p:spPr>
           <a:xfrm>
-            <a:off x="603504" y="6510528"/>
+            <a:off x="603504" y="6236208"/>
             <a:ext cx="3840480" cy="146304"/>
           </a:xfrm>
           <a:prstGeom prst="rect">
@@ -8709,7 +8709,7 @@
             <a:r>
               <a:rPr lang="en-US" sz="950" b="1" spc="120" kern="0" dirty="0">
                 <a:solidFill>
-                  <a:srgbClr val="6F858C"/>
+                  <a:srgbClr val="5D737A"/>
                 </a:solidFill>
                 <a:latin typeface="Calibri" pitchFamily="34" charset="0"/>
                 <a:ea typeface="Calibri" pitchFamily="34" charset="-122"/>
@@ -8729,7 +8729,7 @@
         </p:nvSpPr>
         <p:spPr>
           <a:xfrm>
-            <a:off x="11109960" y="6473952"/>
+            <a:off x="11109960" y="6208776"/>
             <a:ext cx="457200" cy="182880"/>
           </a:xfrm>
           <a:prstGeom prst="rect">
@@ -8961,7 +8961,7 @@
         <p:spPr>
           <a:xfrm>
             <a:off x="941832" y="3566160"/>
-            <a:ext cx="2057400" cy="777240"/>
+            <a:ext cx="2304288" cy="777240"/>
           </a:xfrm>
           <a:prstGeom prst="rect">
             <a:avLst/>
@@ -8979,7 +8979,7 @@
               <a:buNone/>
             </a:pPr>
             <a:r>
-              <a:rPr lang="en-US" sz="1350" dirty="0">
+              <a:rPr lang="en-US" sz="1260" dirty="0">
                 <a:solidFill>
                   <a:srgbClr val="49666F"/>
                 </a:solidFill>
@@ -8987,9 +8987,9 @@
                 <a:ea typeface="Calibri" pitchFamily="34" charset="-122"/>
                 <a:cs typeface="Calibri" pitchFamily="34" charset="-120"/>
               </a:rPr>
-              <a:t>并发、实时性、限流、Prompt 审查与成本优化</a:t>
-            </a:r>
-            <a:endParaRPr lang="en-US" sz="1350" dirty="0"/>
+              <a:t>并发、实时性、限流、Prompt 审查、成本优化</a:t>
+            </a:r>
+            <a:endParaRPr lang="en-US" sz="1260" dirty="0"/>
           </a:p>
         </p:txBody>
       </p:sp>
@@ -9171,7 +9171,7 @@
         <p:spPr>
           <a:xfrm>
             <a:off x="3593592" y="3566160"/>
-            <a:ext cx="2057400" cy="777240"/>
+            <a:ext cx="2304288" cy="777240"/>
           </a:xfrm>
           <a:prstGeom prst="rect">
             <a:avLst/>
@@ -9189,7 +9189,7 @@
               <a:buNone/>
             </a:pPr>
             <a:r>
-              <a:rPr lang="en-US" sz="1350" dirty="0">
+              <a:rPr lang="en-US" sz="1260" dirty="0">
                 <a:solidFill>
                   <a:srgbClr val="49666F"/>
                 </a:solidFill>
@@ -9197,9 +9197,43 @@
                 <a:ea typeface="Calibri" pitchFamily="34" charset="-122"/>
                 <a:cs typeface="Calibri" pitchFamily="34" charset="-120"/>
               </a:rPr>
-              <a:t>上线能力、Actuator、Prometheus 与业务指标</a:t>
-            </a:r>
-            <a:endParaRPr lang="en-US" sz="1350" dirty="0"/>
+              <a:t>部署上线</a:t>
+            </a:r>
+            <a:endParaRPr lang="en-US" sz="1260" dirty="0"/>
+          </a:p>
+          <a:p>
+            <a:pPr indent="0" marL="0">
+              <a:buNone/>
+            </a:pPr>
+            <a:r>
+              <a:rPr lang="en-US" sz="1260" dirty="0">
+                <a:solidFill>
+                  <a:srgbClr val="49666F"/>
+                </a:solidFill>
+                <a:latin typeface="Calibri" pitchFamily="34" charset="0"/>
+                <a:ea typeface="Calibri" pitchFamily="34" charset="-122"/>
+                <a:cs typeface="Calibri" pitchFamily="34" charset="-120"/>
+              </a:rPr>
+              <a:t>Actuator + Prometheus</a:t>
+            </a:r>
+            <a:endParaRPr lang="en-US" sz="1260" dirty="0"/>
+          </a:p>
+          <a:p>
+            <a:pPr indent="0" marL="0">
+              <a:buNone/>
+            </a:pPr>
+            <a:r>
+              <a:rPr lang="en-US" sz="1260" dirty="0">
+                <a:solidFill>
+                  <a:srgbClr val="49666F"/>
+                </a:solidFill>
+                <a:latin typeface="Calibri" pitchFamily="34" charset="0"/>
+                <a:ea typeface="Calibri" pitchFamily="34" charset="-122"/>
+                <a:cs typeface="Calibri" pitchFamily="34" charset="-120"/>
+              </a:rPr>
+              <a:t>业务指标</a:t>
+            </a:r>
+            <a:endParaRPr lang="en-US" sz="1260" dirty="0"/>
           </a:p>
         </p:txBody>
       </p:sp>
@@ -9381,7 +9415,7 @@
         <p:spPr>
           <a:xfrm>
             <a:off x="6245352" y="3566160"/>
-            <a:ext cx="2057400" cy="777240"/>
+            <a:ext cx="2304288" cy="777240"/>
           </a:xfrm>
           <a:prstGeom prst="rect">
             <a:avLst/>
@@ -9399,7 +9433,7 @@
               <a:buNone/>
             </a:pPr>
             <a:r>
-              <a:rPr lang="en-US" sz="1350" dirty="0">
+              <a:rPr lang="en-US" sz="1260" dirty="0">
                 <a:solidFill>
                   <a:srgbClr val="49666F"/>
                 </a:solidFill>
@@ -9409,7 +9443,7 @@
               </a:rPr>
               <a:t>Dubbo + Nacos；用户、应用、AI、截图等 7 模块</a:t>
             </a:r>
-            <a:endParaRPr lang="en-US" sz="1350" dirty="0"/>
+            <a:endParaRPr lang="en-US" sz="1260" dirty="0"/>
           </a:p>
         </p:txBody>
       </p:sp>
@@ -9591,7 +9625,7 @@
         <p:spPr>
           <a:xfrm>
             <a:off x="8897112" y="3566160"/>
-            <a:ext cx="2057400" cy="777240"/>
+            <a:ext cx="2304288" cy="777240"/>
           </a:xfrm>
           <a:prstGeom prst="rect">
             <a:avLst/>
@@ -9609,7 +9643,7 @@
               <a:buNone/>
             </a:pPr>
             <a:r>
-              <a:rPr lang="en-US" sz="1350" dirty="0">
+              <a:rPr lang="en-US" sz="1260" dirty="0">
                 <a:solidFill>
                   <a:srgbClr val="49666F"/>
                 </a:solidFill>
@@ -9617,9 +9651,9 @@
                 <a:ea typeface="Calibri" pitchFamily="34" charset="-122"/>
                 <a:cs typeface="Calibri" pitchFamily="34" charset="-120"/>
               </a:rPr>
-              <a:t>仓库当前处于静止期，未发现昨日变更</a:t>
-            </a:r>
-            <a:endParaRPr lang="en-US" sz="1350" dirty="0"/>
+              <a:t>仓库静止，未发现昨日变更</a:t>
+            </a:r>
+            <a:endParaRPr lang="en-US" sz="1260" dirty="0"/>
           </a:p>
         </p:txBody>
       </p:sp>
@@ -9768,7 +9802,7 @@
         </p:nvSpPr>
         <p:spPr>
           <a:xfrm>
-            <a:off x="621792" y="347472"/>
+            <a:off x="621792" y="457200"/>
             <a:ext cx="4114800" cy="164592"/>
           </a:xfrm>
           <a:prstGeom prst="rect">
@@ -9807,7 +9841,7 @@
         </p:nvSpPr>
         <p:spPr>
           <a:xfrm>
-            <a:off x="603504" y="621792"/>
+            <a:off x="603504" y="731520"/>
             <a:ext cx="9875520" cy="530352"/>
           </a:xfrm>
           <a:prstGeom prst="rect">
@@ -9846,7 +9880,7 @@
         </p:nvSpPr>
         <p:spPr>
           <a:xfrm>
-            <a:off x="10927080" y="347472"/>
+            <a:off x="10927080" y="457200"/>
             <a:ext cx="640080" cy="640080"/>
           </a:xfrm>
           <a:prstGeom prst="ellipse">
@@ -9871,7 +9905,7 @@
         </p:nvSpPr>
         <p:spPr>
           <a:xfrm>
-            <a:off x="10927080" y="521208"/>
+            <a:off x="10927080" y="630936"/>
             <a:ext cx="640080" cy="219456"/>
           </a:xfrm>
           <a:prstGeom prst="rect">
@@ -9910,7 +9944,7 @@
         </p:nvSpPr>
         <p:spPr>
           <a:xfrm>
-            <a:off x="603504" y="6510528"/>
+            <a:off x="603504" y="6236208"/>
             <a:ext cx="3840480" cy="146304"/>
           </a:xfrm>
           <a:prstGeom prst="rect">
@@ -9929,7 +9963,7 @@
             <a:r>
               <a:rPr lang="en-US" sz="950" b="1" spc="120" kern="0" dirty="0">
                 <a:solidFill>
-                  <a:srgbClr val="6F858C"/>
+                  <a:srgbClr val="5D737A"/>
                 </a:solidFill>
                 <a:latin typeface="Calibri" pitchFamily="34" charset="0"/>
                 <a:ea typeface="Calibri" pitchFamily="34" charset="-122"/>
@@ -9949,7 +9983,7 @@
         </p:nvSpPr>
         <p:spPr>
           <a:xfrm>
-            <a:off x="11109960" y="6473952"/>
+            <a:off x="11109960" y="6208776"/>
             <a:ext cx="457200" cy="182880"/>
           </a:xfrm>
           <a:prstGeom prst="rect">
@@ -10139,7 +10173,7 @@
             <a:r>
               <a:rPr lang="en-US" sz="1150" dirty="0">
                 <a:solidFill>
-                  <a:srgbClr val="6F858C"/>
+                  <a:srgbClr val="5D737A"/>
                 </a:solidFill>
                 <a:latin typeface="Calibri" pitchFamily="34" charset="0"/>
                 <a:ea typeface="Calibri" pitchFamily="34" charset="-122"/>
@@ -10310,7 +10344,7 @@
             <a:r>
               <a:rPr lang="en-US" sz="1150" dirty="0">
                 <a:solidFill>
-                  <a:srgbClr val="6F858C"/>
+                  <a:srgbClr val="5D737A"/>
                 </a:solidFill>
                 <a:latin typeface="Calibri" pitchFamily="34" charset="0"/>
                 <a:ea typeface="Calibri" pitchFamily="34" charset="-122"/>
@@ -10481,7 +10515,7 @@
             <a:r>
               <a:rPr lang="en-US" sz="1150" dirty="0">
                 <a:solidFill>
-                  <a:srgbClr val="6F858C"/>
+                  <a:srgbClr val="5D737A"/>
                 </a:solidFill>
                 <a:latin typeface="Calibri" pitchFamily="34" charset="0"/>
                 <a:ea typeface="Calibri" pitchFamily="34" charset="-122"/>
@@ -10652,7 +10686,7 @@
             <a:r>
               <a:rPr lang="en-US" sz="1150" dirty="0">
                 <a:solidFill>
-                  <a:srgbClr val="6F858C"/>
+                  <a:srgbClr val="5D737A"/>
                 </a:solidFill>
                 <a:latin typeface="Calibri" pitchFamily="34" charset="0"/>
                 <a:ea typeface="Calibri" pitchFamily="34" charset="-122"/>
@@ -10823,7 +10857,7 @@
             <a:r>
               <a:rPr lang="en-US" sz="1150" dirty="0">
                 <a:solidFill>
-                  <a:srgbClr val="6F858C"/>
+                  <a:srgbClr val="5D737A"/>
                 </a:solidFill>
                 <a:latin typeface="Calibri" pitchFamily="34" charset="0"/>
                 <a:ea typeface="Calibri" pitchFamily="34" charset="-122"/>
@@ -10994,7 +11028,7 @@
             <a:r>
               <a:rPr lang="en-US" sz="1150" dirty="0">
                 <a:solidFill>
-                  <a:srgbClr val="6F858C"/>
+                  <a:srgbClr val="5D737A"/>
                 </a:solidFill>
                 <a:latin typeface="Calibri" pitchFamily="34" charset="0"/>
                 <a:ea typeface="Calibri" pitchFamily="34" charset="-122"/>
@@ -11031,9 +11065,9 @@
               <a:buNone/>
             </a:pPr>
             <a:r>
-              <a:rPr lang="en-US" sz="1150" i="1" dirty="0">
-                <a:solidFill>
-                  <a:srgbClr val="6F858C"/>
+              <a:rPr lang="en-US" sz="1250" i="1" dirty="0">
+                <a:solidFill>
+                  <a:srgbClr val="49666F"/>
                 </a:solidFill>
                 <a:latin typeface="Calibri" pitchFamily="34" charset="0"/>
                 <a:ea typeface="Calibri" pitchFamily="34" charset="-122"/>
@@ -11041,7 +11075,7 @@
               </a:rPr>
               <a:t>注：以上为 2026-07-15 对仓库内容的静态统计，不代表线上用户量、生成成功率或模型成本等运行时 KPI。</a:t>
             </a:r>
-            <a:endParaRPr lang="en-US" sz="1150" dirty="0"/>
+            <a:endParaRPr lang="en-US" sz="1250" dirty="0"/>
           </a:p>
         </p:txBody>
       </p:sp>
@@ -11085,7 +11119,7 @@
         </p:nvSpPr>
         <p:spPr>
           <a:xfrm>
-            <a:off x="621792" y="347472"/>
+            <a:off x="621792" y="457200"/>
             <a:ext cx="4114800" cy="164592"/>
           </a:xfrm>
           <a:prstGeom prst="rect">
@@ -11124,7 +11158,7 @@
         </p:nvSpPr>
         <p:spPr>
           <a:xfrm>
-            <a:off x="603504" y="621792"/>
+            <a:off x="603504" y="731520"/>
             <a:ext cx="9875520" cy="530352"/>
           </a:xfrm>
           <a:prstGeom prst="rect">
@@ -11163,7 +11197,7 @@
         </p:nvSpPr>
         <p:spPr>
           <a:xfrm>
-            <a:off x="10927080" y="347472"/>
+            <a:off x="10927080" y="457200"/>
             <a:ext cx="640080" cy="640080"/>
           </a:xfrm>
           <a:prstGeom prst="ellipse">
@@ -11188,7 +11222,7 @@
         </p:nvSpPr>
         <p:spPr>
           <a:xfrm>
-            <a:off x="10927080" y="521208"/>
+            <a:off x="10927080" y="630936"/>
             <a:ext cx="640080" cy="219456"/>
           </a:xfrm>
           <a:prstGeom prst="rect">
@@ -11227,7 +11261,7 @@
         </p:nvSpPr>
         <p:spPr>
           <a:xfrm>
-            <a:off x="603504" y="6510528"/>
+            <a:off x="603504" y="6236208"/>
             <a:ext cx="3840480" cy="146304"/>
           </a:xfrm>
           <a:prstGeom prst="rect">
@@ -11246,7 +11280,7 @@
             <a:r>
               <a:rPr lang="en-US" sz="950" b="1" spc="120" kern="0" dirty="0">
                 <a:solidFill>
-                  <a:srgbClr val="6F858C"/>
+                  <a:srgbClr val="5D737A"/>
                 </a:solidFill>
                 <a:latin typeface="Calibri" pitchFamily="34" charset="0"/>
                 <a:ea typeface="Calibri" pitchFamily="34" charset="-122"/>
@@ -11266,7 +11300,7 @@
         </p:nvSpPr>
         <p:spPr>
           <a:xfrm>
-            <a:off x="11109960" y="6473952"/>
+            <a:off x="11109960" y="6208776"/>
             <a:ext cx="457200" cy="182880"/>
           </a:xfrm>
           <a:prstGeom prst="rect">
@@ -11488,7 +11522,7 @@
               <a:buNone/>
             </a:pPr>
             <a:r>
-              <a:rPr lang="en-US" sz="1360" b="1" dirty="0">
+              <a:rPr lang="en-US" sz="1280" b="1" dirty="0">
                 <a:solidFill>
                   <a:srgbClr val="143642"/>
                 </a:solidFill>
@@ -11496,9 +11530,9 @@
                 <a:ea typeface="Calibri" pitchFamily="34" charset="-122"/>
                 <a:cs typeface="Calibri" pitchFamily="34" charset="-120"/>
               </a:rPr>
-              <a:t>对话历史删除仅前端假操作</a:t>
-            </a:r>
-            <a:endParaRPr lang="en-US" sz="1360" dirty="0"/>
+              <a:t>对话删除尚未接通后端</a:t>
+            </a:r>
+            <a:endParaRPr lang="en-US" sz="1280" dirty="0"/>
           </a:p>
         </p:txBody>
       </p:sp>
@@ -11595,7 +11629,7 @@
               <a:buNone/>
             </a:pPr>
             <a:r>
-              <a:rPr lang="en-US" sz="1360" dirty="0">
+              <a:rPr lang="en-US" sz="1280" dirty="0">
                 <a:solidFill>
                   <a:srgbClr val="143642"/>
                 </a:solidFill>
@@ -11603,9 +11637,9 @@
                 <a:ea typeface="Calibri" pitchFamily="34" charset="-122"/>
                 <a:cs typeface="Calibri" pitchFamily="34" charset="-120"/>
               </a:rPr>
-              <a:t>浏览 view=1 模式未消费</a:t>
-            </a:r>
-            <a:endParaRPr lang="en-US" sz="1360" dirty="0"/>
+              <a:t>view=1 模式待实现</a:t>
+            </a:r>
+            <a:endParaRPr lang="en-US" sz="1280" dirty="0"/>
           </a:p>
         </p:txBody>
       </p:sp>
@@ -11702,7 +11736,7 @@
               <a:buNone/>
             </a:pPr>
             <a:r>
-              <a:rPr lang="en-US" sz="1360" dirty="0">
+              <a:rPr lang="en-US" sz="1280" dirty="0">
                 <a:solidFill>
                   <a:srgbClr val="143642"/>
                 </a:solidFill>
@@ -11710,9 +11744,9 @@
                 <a:ea typeface="Calibri" pitchFamily="34" charset="-122"/>
                 <a:cs typeface="Calibri" pitchFamily="34" charset="-120"/>
               </a:rPr>
-              <a:t>登录 redirect 参数未回跳</a:t>
-            </a:r>
-            <a:endParaRPr lang="en-US" sz="1360" dirty="0"/>
+              <a:t>登录 redirect 未回跳</a:t>
+            </a:r>
+            <a:endParaRPr lang="en-US" sz="1280" dirty="0"/>
           </a:p>
         </p:txBody>
       </p:sp>
@@ -11907,7 +11941,7 @@
               <a:buNone/>
             </a:pPr>
             <a:r>
-              <a:rPr lang="en-US" sz="1360" b="1" dirty="0">
+              <a:rPr lang="en-US" sz="1280" b="1" dirty="0">
                 <a:solidFill>
                   <a:srgbClr val="143642"/>
                 </a:solidFill>
@@ -11915,9 +11949,9 @@
                 <a:ea typeface="Calibri" pitchFamily="34" charset="-122"/>
                 <a:cs typeface="Calibri" pitchFamily="34" charset="-120"/>
               </a:rPr>
-              <a:t>微服务缺 LangGraph 工作流</a:t>
-            </a:r>
-            <a:endParaRPr lang="en-US" sz="1360" dirty="0"/>
+              <a:t>微服务缺少 LangGraph 工作流</a:t>
+            </a:r>
+            <a:endParaRPr lang="en-US" sz="1280" dirty="0"/>
           </a:p>
         </p:txBody>
       </p:sp>
@@ -12014,7 +12048,7 @@
               <a:buNone/>
             </a:pPr>
             <a:r>
-              <a:rPr lang="en-US" sz="1360" dirty="0">
+              <a:rPr lang="en-US" sz="1280" dirty="0">
                 <a:solidFill>
                   <a:srgbClr val="143642"/>
                 </a:solidFill>
@@ -12022,9 +12056,9 @@
                 <a:ea typeface="Calibri" pitchFamily="34" charset="-122"/>
                 <a:cs typeface="Calibri" pitchFamily="34" charset="-120"/>
               </a:rPr>
-              <a:t>无统一 API Gateway</a:t>
-            </a:r>
-            <a:endParaRPr lang="en-US" sz="1360" dirty="0"/>
+              <a:t>缺少统一 API Gateway</a:t>
+            </a:r>
+            <a:endParaRPr lang="en-US" sz="1280" dirty="0"/>
           </a:p>
         </p:txBody>
       </p:sp>
@@ -12121,7 +12155,7 @@
               <a:buNone/>
             </a:pPr>
             <a:r>
-              <a:rPr lang="en-US" sz="1360" dirty="0">
+              <a:rPr lang="en-US" sz="1280" dirty="0">
                 <a:solidFill>
                   <a:srgbClr val="143642"/>
                 </a:solidFill>
@@ -12129,9 +12163,9 @@
                 <a:ea typeface="Calibri" pitchFamily="34" charset="-122"/>
                 <a:cs typeface="Calibri" pitchFamily="34" charset="-120"/>
               </a:rPr>
-              <a:t>单体与微服务代码双轨维护</a:t>
-            </a:r>
-            <a:endParaRPr lang="en-US" sz="1360" dirty="0"/>
+              <a:t>单体 / 微服务双轨维护</a:t>
+            </a:r>
+            <a:endParaRPr lang="en-US" sz="1280" dirty="0"/>
           </a:p>
         </p:txBody>
       </p:sp>
@@ -12326,7 +12360,7 @@
               <a:buNone/>
             </a:pPr>
             <a:r>
-              <a:rPr lang="en-US" sz="1360" b="1" dirty="0">
+              <a:rPr lang="en-US" sz="1280" b="1" dirty="0">
                 <a:solidFill>
                   <a:srgbClr val="143642"/>
                 </a:solidFill>
@@ -12334,9 +12368,9 @@
                 <a:ea typeface="Calibri" pitchFamily="34" charset="-122"/>
                 <a:cs typeface="Calibri" pitchFamily="34" charset="-120"/>
               </a:rPr>
-              <a:t>微服务与前端无自动化测试</a:t>
-            </a:r>
-            <a:endParaRPr lang="en-US" sz="1360" dirty="0"/>
+              <a:t>微服务与前端没有测试</a:t>
+            </a:r>
+            <a:endParaRPr lang="en-US" sz="1280" dirty="0"/>
           </a:p>
         </p:txBody>
       </p:sp>
@@ -12433,7 +12467,7 @@
               <a:buNone/>
             </a:pPr>
             <a:r>
-              <a:rPr lang="en-US" sz="1360" dirty="0">
+              <a:rPr lang="en-US" sz="1280" dirty="0">
                 <a:solidFill>
                   <a:srgbClr val="143642"/>
                 </a:solidFill>
@@ -12441,9 +12475,9 @@
                 <a:ea typeface="Calibri" pitchFamily="34" charset="-122"/>
                 <a:cs typeface="Calibri" pitchFamily="34" charset="-120"/>
               </a:rPr>
-              <a:t>无 CI/CD 工作流</a:t>
-            </a:r>
-            <a:endParaRPr lang="en-US" sz="1360" dirty="0"/>
+              <a:t>没有 CI/CD 工作流</a:t>
+            </a:r>
+            <a:endParaRPr lang="en-US" sz="1280" dirty="0"/>
           </a:p>
         </p:txBody>
       </p:sp>
@@ -12540,7 +12574,7 @@
               <a:buNone/>
             </a:pPr>
             <a:r>
-              <a:rPr lang="en-US" sz="1360" dirty="0">
+              <a:rPr lang="en-US" sz="1280" dirty="0">
                 <a:solidFill>
                   <a:srgbClr val="143642"/>
                 </a:solidFill>
@@ -12548,9 +12582,9 @@
                 <a:ea typeface="Calibri" pitchFamily="34" charset="-122"/>
                 <a:cs typeface="Calibri" pitchFamily="34" charset="-120"/>
               </a:rPr>
-              <a:t>密钥、COS、数据库需手工配置</a:t>
-            </a:r>
-            <a:endParaRPr lang="en-US" sz="1360" dirty="0"/>
+              <a:t>密钥与环境需手工配置</a:t>
+            </a:r>
+            <a:endParaRPr lang="en-US" sz="1280" dirty="0"/>
           </a:p>
         </p:txBody>
       </p:sp>
@@ -12594,7 +12628,7 @@
         </p:nvSpPr>
         <p:spPr>
           <a:xfrm>
-            <a:off x="621792" y="347472"/>
+            <a:off x="621792" y="457200"/>
             <a:ext cx="4114800" cy="164592"/>
           </a:xfrm>
           <a:prstGeom prst="rect">
@@ -12633,7 +12667,7 @@
         </p:nvSpPr>
         <p:spPr>
           <a:xfrm>
-            <a:off x="603504" y="621792"/>
+            <a:off x="603504" y="731520"/>
             <a:ext cx="9875520" cy="530352"/>
           </a:xfrm>
           <a:prstGeom prst="rect">
@@ -12672,7 +12706,7 @@
         </p:nvSpPr>
         <p:spPr>
           <a:xfrm>
-            <a:off x="10927080" y="347472"/>
+            <a:off x="10927080" y="457200"/>
             <a:ext cx="640080" cy="640080"/>
           </a:xfrm>
           <a:prstGeom prst="ellipse">
@@ -12697,7 +12731,7 @@
         </p:nvSpPr>
         <p:spPr>
           <a:xfrm>
-            <a:off x="10927080" y="521208"/>
+            <a:off x="10927080" y="630936"/>
             <a:ext cx="640080" cy="219456"/>
           </a:xfrm>
           <a:prstGeom prst="rect">
@@ -12736,7 +12770,7 @@
         </p:nvSpPr>
         <p:spPr>
           <a:xfrm>
-            <a:off x="603504" y="6510528"/>
+            <a:off x="603504" y="6236208"/>
             <a:ext cx="3840480" cy="146304"/>
           </a:xfrm>
           <a:prstGeom prst="rect">
@@ -12755,7 +12789,7 @@
             <a:r>
               <a:rPr lang="en-US" sz="950" b="1" spc="120" kern="0" dirty="0">
                 <a:solidFill>
-                  <a:srgbClr val="6F858C"/>
+                  <a:srgbClr val="5D737A"/>
                 </a:solidFill>
                 <a:latin typeface="Calibri" pitchFamily="34" charset="0"/>
                 <a:ea typeface="Calibri" pitchFamily="34" charset="-122"/>
@@ -12775,7 +12809,7 @@
         </p:nvSpPr>
         <p:spPr>
           <a:xfrm>
-            <a:off x="11109960" y="6473952"/>
+            <a:off x="11109960" y="6208776"/>
             <a:ext cx="457200" cy="182880"/>
           </a:xfrm>
           <a:prstGeom prst="rect">
@@ -12833,7 +12867,7 @@
             <a:r>
               <a:rPr lang="en-US" sz="1200" b="1" dirty="0">
                 <a:solidFill>
-                  <a:srgbClr val="6F858C"/>
+                  <a:srgbClr val="5D737A"/>
                 </a:solidFill>
                 <a:latin typeface="Calibri" pitchFamily="34" charset="0"/>
                 <a:ea typeface="Calibri" pitchFamily="34" charset="-122"/>
@@ -12872,7 +12906,7 @@
             <a:r>
               <a:rPr lang="en-US" sz="1200" b="1" dirty="0">
                 <a:solidFill>
-                  <a:srgbClr val="6F858C"/>
+                  <a:srgbClr val="5D737A"/>
                 </a:solidFill>
                 <a:latin typeface="Calibri" pitchFamily="34" charset="0"/>
                 <a:ea typeface="Calibri" pitchFamily="34" charset="-122"/>
@@ -12889,7 +12923,7 @@
             <a:r>
               <a:rPr lang="en-US" sz="1200" b="1" dirty="0">
                 <a:solidFill>
-                  <a:srgbClr val="6F858C"/>
+                  <a:srgbClr val="5D737A"/>
                 </a:solidFill>
                 <a:latin typeface="Calibri" pitchFamily="34" charset="0"/>
                 <a:ea typeface="Calibri" pitchFamily="34" charset="-122"/>
@@ -12953,7 +12987,7 @@
             <a:r>
               <a:rPr lang="en-US" sz="1350" b="1" dirty="0">
                 <a:solidFill>
-                  <a:srgbClr val="F4B860"/>
+                  <a:srgbClr val="E76F51"/>
                 </a:solidFill>
                 <a:latin typeface="Calibri" pitchFamily="34" charset="0"/>
                 <a:ea typeface="Calibri" pitchFamily="34" charset="-122"/>
@@ -12980,11 +13014,11 @@
             <a:avLst/>
           </a:prstGeom>
           <a:solidFill>
-            <a:srgbClr val="F4B860"/>
+            <a:srgbClr val="E76F51"/>
           </a:solidFill>
           <a:ln w="12700">
             <a:solidFill>
-              <a:srgbClr val="F4B860"/>
+              <a:srgbClr val="E76F51"/>
             </a:solidFill>
             <a:prstDash val="solid"/>
           </a:ln>
@@ -13046,11 +13080,11 @@
             <a:avLst/>
           </a:prstGeom>
           <a:solidFill>
-            <a:srgbClr val="F4B860"/>
+            <a:srgbClr val="E76F51"/>
           </a:solidFill>
           <a:ln w="12700">
             <a:solidFill>
-              <a:srgbClr val="F4B860"/>
+              <a:srgbClr val="E76F51"/>
             </a:solidFill>
             <a:prstDash val="solid"/>
           </a:ln>
@@ -14240,6 +14274,72 @@
               <a:t>发布与回归依赖人工判断</a:t>
             </a:r>
             <a:endParaRPr lang="en-US" sz="1400" dirty="0"/>
+          </a:p>
+        </p:txBody>
+      </p:sp>
+      <p:sp>
+        <p:nvSpPr>
+          <p:cNvPr id="51" name="Shape 49"/>
+          <p:cNvSpPr/>
+          <p:nvPr/>
+        </p:nvSpPr>
+        <p:spPr>
+          <a:xfrm>
+            <a:off x="8705088" y="4626864"/>
+            <a:ext cx="1810512" cy="320040"/>
+          </a:xfrm>
+          <a:prstGeom prst="roundRect">
+            <a:avLst>
+              <a:gd name="adj" fmla="val 22857"/>
+            </a:avLst>
+          </a:prstGeom>
+          <a:solidFill>
+            <a:srgbClr val="02C39A"/>
+          </a:solidFill>
+          <a:ln w="12700">
+            <a:solidFill>
+              <a:srgbClr val="02C39A"/>
+            </a:solidFill>
+            <a:prstDash val="solid"/>
+          </a:ln>
+        </p:spPr>
+      </p:sp>
+      <p:sp>
+        <p:nvSpPr>
+          <p:cNvPr id="52" name="Text 50"/>
+          <p:cNvSpPr/>
+          <p:nvPr/>
+        </p:nvSpPr>
+        <p:spPr>
+          <a:xfrm>
+            <a:off x="8705088" y="4713732"/>
+            <a:ext cx="1810512" cy="137160"/>
+          </a:xfrm>
+          <a:prstGeom prst="rect">
+            <a:avLst/>
+          </a:prstGeom>
+          <a:noFill/>
+          <a:ln/>
+        </p:spPr>
+        <p:txBody>
+          <a:bodyPr wrap="square" lIns="0" tIns="0" rIns="0" bIns="0" rtlCol="0" anchor="ctr"/>
+          <a:lstStyle/>
+          <a:p>
+            <a:pPr algn="ctr" indent="0" marL="0">
+              <a:buNone/>
+            </a:pPr>
+            <a:r>
+              <a:rPr lang="en-US" sz="1000" b="1" dirty="0">
+                <a:solidFill>
+                  <a:srgbClr val="073B4C"/>
+                </a:solidFill>
+                <a:latin typeface="Calibri" pitchFamily="34" charset="0"/>
+                <a:ea typeface="Calibri" pitchFamily="34" charset="-122"/>
+                <a:cs typeface="Calibri" pitchFamily="34" charset="-120"/>
+              </a:rPr>
+              <a:t>P0 · 先解除链式阻塞</a:t>
+            </a:r>
+            <a:endParaRPr lang="en-US" sz="1000" dirty="0"/>
           </a:p>
         </p:txBody>
       </p:sp>
@@ -14283,7 +14383,7 @@
         </p:nvSpPr>
         <p:spPr>
           <a:xfrm>
-            <a:off x="621792" y="347472"/>
+            <a:off x="621792" y="457200"/>
             <a:ext cx="4114800" cy="164592"/>
           </a:xfrm>
           <a:prstGeom prst="rect">
@@ -14322,7 +14422,7 @@
         </p:nvSpPr>
         <p:spPr>
           <a:xfrm>
-            <a:off x="603504" y="621792"/>
+            <a:off x="603504" y="731520"/>
             <a:ext cx="9875520" cy="530352"/>
           </a:xfrm>
           <a:prstGeom prst="rect">
@@ -14347,7 +14447,7 @@
                 <a:ea typeface="Georgia" pitchFamily="34" charset="-122"/>
                 <a:cs typeface="Georgia" pitchFamily="34" charset="-120"/>
               </a:rPr>
-              <a:t>测试与 CI：有单体测试，缺自动化门禁</a:t>
+              <a:t>测试 / CI：有单体测试，缺自动化门禁</a:t>
             </a:r>
             <a:endParaRPr lang="en-US" sz="3600" dirty="0"/>
           </a:p>
@@ -14361,7 +14461,7 @@
         </p:nvSpPr>
         <p:spPr>
           <a:xfrm>
-            <a:off x="10927080" y="347472"/>
+            <a:off x="10927080" y="457200"/>
             <a:ext cx="640080" cy="640080"/>
           </a:xfrm>
           <a:prstGeom prst="ellipse">
@@ -14386,7 +14486,7 @@
         </p:nvSpPr>
         <p:spPr>
           <a:xfrm>
-            <a:off x="10927080" y="521208"/>
+            <a:off x="10927080" y="630936"/>
             <a:ext cx="640080" cy="219456"/>
           </a:xfrm>
           <a:prstGeom prst="rect">
@@ -14425,7 +14525,7 @@
         </p:nvSpPr>
         <p:spPr>
           <a:xfrm>
-            <a:off x="603504" y="6510528"/>
+            <a:off x="603504" y="6236208"/>
             <a:ext cx="3840480" cy="146304"/>
           </a:xfrm>
           <a:prstGeom prst="rect">
@@ -14444,7 +14544,7 @@
             <a:r>
               <a:rPr lang="en-US" sz="950" b="1" spc="120" kern="0" dirty="0">
                 <a:solidFill>
-                  <a:srgbClr val="6F858C"/>
+                  <a:srgbClr val="5D737A"/>
                 </a:solidFill>
                 <a:latin typeface="Calibri" pitchFamily="34" charset="0"/>
                 <a:ea typeface="Calibri" pitchFamily="34" charset="-122"/>
@@ -14464,7 +14564,7 @@
         </p:nvSpPr>
         <p:spPr>
           <a:xfrm>
-            <a:off x="11109960" y="6473952"/>
+            <a:off x="11109960" y="6208776"/>
             <a:ext cx="457200" cy="182880"/>
           </a:xfrm>
           <a:prstGeom prst="rect">
@@ -14627,7 +14727,7 @@
             <a:r>
               <a:rPr lang="en-US" sz="1150" dirty="0">
                 <a:solidFill>
-                  <a:srgbClr val="6F858C"/>
+                  <a:srgbClr val="5D737A"/>
                 </a:solidFill>
                 <a:latin typeface="Calibri" pitchFamily="34" charset="0"/>
                 <a:ea typeface="Calibri" pitchFamily="34" charset="-122"/>
@@ -14771,7 +14871,7 @@
             <a:r>
               <a:rPr lang="en-US" sz="1150" dirty="0">
                 <a:solidFill>
-                  <a:srgbClr val="6F858C"/>
+                  <a:srgbClr val="5D737A"/>
                 </a:solidFill>
                 <a:latin typeface="Calibri" pitchFamily="34" charset="0"/>
                 <a:ea typeface="Calibri" pitchFamily="34" charset="-122"/>
@@ -14915,7 +15015,7 @@
             <a:r>
               <a:rPr lang="en-US" sz="1150" dirty="0">
                 <a:solidFill>
-                  <a:srgbClr val="6F858C"/>
+                  <a:srgbClr val="5D737A"/>
                 </a:solidFill>
                 <a:latin typeface="Calibri" pitchFamily="34" charset="0"/>
                 <a:ea typeface="Calibri" pitchFamily="34" charset="-122"/>
@@ -15059,7 +15159,7 @@
             <a:r>
               <a:rPr lang="en-US" sz="1150" dirty="0">
                 <a:solidFill>
-                  <a:srgbClr val="6F858C"/>
+                  <a:srgbClr val="5D737A"/>
                 </a:solidFill>
                 <a:latin typeface="Calibri" pitchFamily="34" charset="0"/>
                 <a:ea typeface="Calibri" pitchFamily="34" charset="-122"/>

</xml_diff>